<commit_message>
Complete analysis of "Who Knows Like Us" from the full story text
Replace the placeholder sections for the second story with the full plot
(the writer's losses, minimalism, the hidden underwear, the sunset and the
stuck neck) in the outline, presentation and README.

Co-Authored-By: Claude Fable 5.1 <noreply@anthropic.com>
Claude-Session: https://claude.ai/code/session_012ZD2wAUBZdU4RRE8wFJx9h
</commit_message>
<xml_diff>
--- a/seminar/מצגת-סמינריון-קרת.pptx
+++ b/seminar/מצגת-סמינריון-קרת.pptx
@@ -2631,7 +2631,7 @@
                           <a:ea typeface="Arial" pitchFamily="34" charset="-122"/>
                           <a:cs typeface="Arial" pitchFamily="34" charset="-120"/>
                         </a:rPr>
-                        <a:t>בדידות, ניכור, צורך בהכרה</a:t>
+                        <a:t>אובדן ילד וגירושים (הזר); בדידות ומבוכה (המספר)</a:t>
                       </a:r>
                       <a:endParaRPr lang="en-US" sz="1150" dirty="0">
                         <a:latin typeface="Arial" charset="0"/>
@@ -3043,7 +3043,7 @@
                           <a:ea typeface="Arial" pitchFamily="34" charset="-122"/>
                           <a:cs typeface="Arial" pitchFamily="34" charset="-120"/>
                         </a:rPr>
-                        <a:t>דיבור בלתי פוסק, נוסחת שייכות, יצירה</a:t>
+                        <a:t>דיבור בלתי פוסק, מינימליזם, הסתרה, כתיבה</a:t>
                       </a:r>
                       <a:endParaRPr lang="en-US" sz="1150" dirty="0">
                         <a:latin typeface="Arial" charset="0"/>
@@ -3661,7 +3661,7 @@
                           <a:ea typeface="Arial" pitchFamily="34" charset="-122"/>
                           <a:cs typeface="Arial" pitchFamily="34" charset="-120"/>
                         </a:rPr>
-                        <a:t>אחדות מדומה, כאב משותף [להשלים]</a:t>
+                        <a:t>ויתור על העצמי, "אנחנו" מזויף, צוואר תפוס</a:t>
                       </a:r>
                       <a:endParaRPr lang="en-US" sz="1150" dirty="0">
                         <a:latin typeface="Arial" charset="0"/>
@@ -4535,7 +4535,7 @@
                 <a:ea typeface="Arial" pitchFamily="34" charset="-122"/>
                 <a:cs typeface="Arial" pitchFamily="34" charset="-120"/>
               </a:rPr>
-              <a:t>מן הסיפור המוקדם למאוחר: מן הבית הסגור אל הדיבור אל הזר – אך גם השייכות היא "לב כואב". הריקון ("סתם") והאחדות המדומה הם שני פנים של אותו מחיר.</a:t>
+              <a:t>מן הסיפור המוקדם למאוחר: מן הבית הסגור אל הדיבור עם הזר – אך גם השייכות היא "לב כואב" וצוואר תפוס. הריקון ("סתם") וההנהון המזויף הם שני פנים של אותו מחיר.</a:t>
             </a:r>
             <a:endParaRPr lang="en-US" sz="1150" dirty="0"/>
           </a:p>
@@ -5312,7 +5312,7 @@
                 <a:ea typeface="Arial" pitchFamily="34" charset="-122"/>
                 <a:cs typeface="Arial" pitchFamily="34" charset="-120"/>
               </a:rPr>
-              <a:t>פרק 3 – "מי כמונו יודע": דיבור, שותפות ויצירה</a:t>
+              <a:t>פרק 3 – "מי כמונו יודע": דיבור, אידאולוגיה, הסתרה וכתיבה</a:t>
             </a:r>
             <a:endParaRPr lang="en-US" sz="1200" dirty="0"/>
           </a:p>
@@ -11108,7 +11108,7 @@
                 <a:ea typeface="Arial" pitchFamily="34" charset="-122"/>
                 <a:cs typeface="Arial" pitchFamily="34" charset="-120"/>
               </a:rPr>
-              <a:t>מפגש בבית קפה בין המספר לבין זר אמריקאי שאינו מפסיק לדבר – וסיפור על מילים שמנסות לבנות "אנחנו".</a:t>
+              <a:t>מפגש בבית קפה בין המספר לבין סופר אמריקאי שאינו מפסיק לדבר – סיפור על מילים שבונות "אנחנו" מזויף, ועל צוואר שנתפס.</a:t>
             </a:r>
             <a:endParaRPr lang="en-US" sz="1300" dirty="0"/>
           </a:p>
@@ -11300,7 +11300,7 @@
                 <a:ea typeface="Arial" pitchFamily="34" charset="-122"/>
                 <a:cs typeface="Arial" pitchFamily="34" charset="-120"/>
               </a:rPr>
-              <a:t>אמריקאי, סופר שכתב שלושה ספרים וזכה בפרס חשוב "שלא שמעתי עליו מעולם".</a:t>
+              <a:t>סופר אמריקאי, שלושה ספרים ופרס "שלא שמעתי עליו"; כל משפט שני: "ומי כמונו יודע..."</a:t>
             </a:r>
             <a:endParaRPr lang="en-US" sz="1050" dirty="0"/>
           </a:p>
@@ -11430,7 +11430,7 @@
                 <a:ea typeface="Arial" pitchFamily="34" charset="-122"/>
                 <a:cs typeface="Arial" pitchFamily="34" charset="-120"/>
               </a:rPr>
-              <a:t>הדיבור</a:t>
+              <a:t>החיים שהתפרקו</a:t>
             </a:r>
             <a:endParaRPr lang="en-US" sz="1400" dirty="0"/>
           </a:p>
@@ -11469,7 +11469,7 @@
                 <a:ea typeface="Arial" pitchFamily="34" charset="-122"/>
                 <a:cs typeface="Arial" pitchFamily="34" charset="-120"/>
               </a:rPr>
-              <a:t>מדבר מהר, "כאילו יש לו יותר מדי דברים להגיד והוא חייב להספיק את כולם".</a:t>
+              <a:t>ילד שנהרג בתאונה, גירושים, גיור והתפקרות, מינימליזם: "שני זוגות תחתונים ועט אחד".</a:t>
             </a:r>
             <a:endParaRPr lang="en-US" sz="1050" dirty="0"/>
           </a:p>
@@ -11599,7 +11599,7 @@
                 <a:ea typeface="Arial" pitchFamily="34" charset="-122"/>
                 <a:cs typeface="Arial" pitchFamily="34" charset="-120"/>
               </a:rPr>
-              <a:t>הנוסחה</a:t>
+              <a:t>השקר</a:t>
             </a:r>
             <a:endParaRPr lang="en-US" sz="1400" dirty="0"/>
           </a:p>
@@ -11638,7 +11638,7 @@
                 <a:ea typeface="Arial" pitchFamily="34" charset="-122"/>
                 <a:cs typeface="Arial" pitchFamily="34" charset="-120"/>
               </a:rPr>
-              <a:t>כל משפט שני נפתח ב"ומי כמונו יודע..." – המאזין נעשה שותף בעל כורחו.</a:t>
+              <a:t>המספר מסתיר את עשרים זוגות התחתונים: "פחדתי שזה ירחיק בינינו".</a:t>
             </a:r>
             <a:endParaRPr lang="en-US" sz="1050" dirty="0"/>
           </a:p>
@@ -11768,7 +11768,7 @@
                 <a:ea typeface="Arial" pitchFamily="34" charset="-122"/>
                 <a:cs typeface="Arial" pitchFamily="34" charset="-120"/>
               </a:rPr>
-              <a:t>לב אחד</a:t>
+              <a:t>השקיעה</a:t>
             </a:r>
             <a:endParaRPr lang="en-US" sz="1400" dirty="0"/>
           </a:p>
@@ -11807,7 +11807,7 @@
                 <a:ea typeface="Arial" pitchFamily="34" charset="-122"/>
                 <a:cs typeface="Arial" pitchFamily="34" charset="-120"/>
               </a:rPr>
-              <a:t>"תאומים סיאמיים... חולקים לב אחד גדול וכואב שפועם כמו מטרונום ענקי".</a:t>
+              <a:t>"אתה ואני יכולים, בעזרת הכתיבה, לשמר את היופי הזה לנצח" – והצוואר מתחיל לכאוב.</a:t>
             </a:r>
             <a:endParaRPr lang="en-US" sz="1050" dirty="0"/>
           </a:p>
@@ -11937,7 +11937,7 @@
                 <a:ea typeface="Arial" pitchFamily="34" charset="-122"/>
                 <a:cs typeface="Arial" pitchFamily="34" charset="-120"/>
               </a:rPr>
-              <a:t>היצירה</a:t>
+              <a:t>הסיום</a:t>
             </a:r>
             <a:endParaRPr lang="en-US" sz="1400" dirty="0"/>
           </a:p>
@@ -11976,7 +11976,7 @@
                 <a:ea typeface="Arial" pitchFamily="34" charset="-122"/>
                 <a:cs typeface="Arial" pitchFamily="34" charset="-120"/>
               </a:rPr>
-              <a:t>"יצירה היא בסך הכול פעולת הסחה" – ואל הסיום [להשלים לפי הטקסט המלא].</a:t>
+              <a:t>"גם אני" – והסיפור הבא: "על מישהו שנתפס לו הצוואר".</a:t>
             </a:r>
             <a:endParaRPr lang="en-US" sz="1050" dirty="0"/>
           </a:p>
@@ -12176,7 +12176,7 @@
               <a:buNone/>
             </a:pPr>
             <a:r>
-              <a:rPr lang="en-US" sz="1350" i="1" dirty="0">
+              <a:rPr lang="en-US" sz="1300" i="1" dirty="0">
                 <a:solidFill>
                   <a:srgbClr val="FFFFFF"/>
                 </a:solidFill>
@@ -12184,9 +12184,9 @@
                 <a:ea typeface="Arial" pitchFamily="34" charset="-122"/>
                 <a:cs typeface="Arial" pitchFamily="34" charset="-120"/>
               </a:rPr>
-              <a:t>"זה גרם לי להרגיש כאילו אנחנו ישות אחת, תאומים סיאמיים שאמנם יכולים לנופף עצמאית, כל אחד בזרועותיו שלו, אבל חולקים לב אחד גדול וכואב..."</a:t>
-            </a:r>
-            <a:endParaRPr lang="en-US" sz="1350" dirty="0"/>
+              <a:t>"אני ואתה, אנחנו בני מזל... אתה ואני יכולים, בעזרת הכתיבה, לשמר את היופי הזה לנצח." זאת באמת היתה שקיעה יפה, אבל הצוואר שלי התחיל לכאוב.</a:t>
+            </a:r>
+            <a:endParaRPr lang="en-US" sz="1300" dirty="0"/>
           </a:p>
         </p:txBody>
       </p:sp>
@@ -12223,7 +12223,7 @@
                 <a:ea typeface="Arial" pitchFamily="34" charset="-122"/>
                 <a:cs typeface="Arial" pitchFamily="34" charset="-120"/>
               </a:rPr>
-              <a:t>"ומי כמונו יודע, שיצירה היא בסך הכול פעולת הסחה..."</a:t>
+              <a:t>"כבר אז ידעתי שהסיפור הבא שלי הולך להיות על מישהו שנתפס לו הצוואר."</a:t>
             </a:r>
             <a:endParaRPr lang="en-US" sz="1300" dirty="0"/>
           </a:p>
@@ -12353,7 +12353,7 @@
                 <a:ea typeface="Arial" pitchFamily="34" charset="-122"/>
                 <a:cs typeface="Arial" pitchFamily="34" charset="-120"/>
               </a:rPr>
-              <a:t>דיבור בלתי פוסק = ויסות רגשי</a:t>
+              <a:t>דיבור ו"ומי כמונו יודע" = חיפוש שייכות</a:t>
             </a:r>
             <a:endParaRPr lang="en-US" sz="1250" dirty="0"/>
           </a:p>
@@ -12392,7 +12392,7 @@
                 <a:ea typeface="Arial" pitchFamily="34" charset="-122"/>
                 <a:cs typeface="Arial" pitchFamily="34" charset="-120"/>
               </a:rPr>
-              <a:t>הדיבור הכפוי הוא סימן למצוקה וגם דרך לשלוט בה – התמודדות ממוקדת-רגש.</a:t>
+              <a:t>הנוסחה החוזרת בונה "אנחנו" עם זר – ויסות רגשי וחיפוש תמיכה (Lazarus &amp; Folkman, 1984).</a:t>
             </a:r>
             <a:endParaRPr lang="en-US" sz="1050" dirty="0"/>
           </a:p>
@@ -12522,7 +12522,7 @@
                 <a:ea typeface="Arial" pitchFamily="34" charset="-122"/>
                 <a:cs typeface="Arial" pitchFamily="34" charset="-120"/>
               </a:rPr>
-              <a:t>"ומי כמונו יודע" = חיפוש שייכות</a:t>
+              <a:t>מינימליזם ואמונות = בנייה מחדש של החיים</a:t>
             </a:r>
             <a:endParaRPr lang="en-US" sz="1250" dirty="0"/>
           </a:p>
@@ -12561,7 +12561,7 @@
                 <a:ea typeface="Arial" pitchFamily="34" charset="-122"/>
                 <a:cs typeface="Arial" pitchFamily="34" charset="-120"/>
               </a:rPr>
-              <a:t>הנוסחה החוזרת בונה "אנחנו" עם זר; תמיכה חברתית שנכפית על המאזין.</a:t>
+              <a:t>אחרי מות הילד והגירושים: גיור, התפקרות, "עט אחד". פתרון לכאורה – הימנעות למעשה (Rubin, 1999).</a:t>
             </a:r>
             <a:endParaRPr lang="en-US" sz="1050" dirty="0"/>
           </a:p>
@@ -12691,7 +12691,7 @@
                 <a:ea typeface="Arial" pitchFamily="34" charset="-122"/>
                 <a:cs typeface="Arial" pitchFamily="34" charset="-120"/>
               </a:rPr>
-              <a:t>תאומים סיאמיים = אמפתיה</a:t>
+              <a:t>הסתרה והנהון = שמירה על הקשר</a:t>
             </a:r>
             <a:endParaRPr lang="en-US" sz="1250" dirty="0"/>
           </a:p>
@@ -12730,7 +12730,7 @@
                 <a:ea typeface="Arial" pitchFamily="34" charset="-122"/>
                 <a:cs typeface="Arial" pitchFamily="34" charset="-120"/>
               </a:rPr>
-              <a:t>דימוי גופני-פנטסטי אופייני לקרת: כאב שנחלק בין שניים נעשה נסבל – ומחייב.</a:t>
+              <a:t>המספר משקר על התחתונים ומסתובב "מתוך נימוס" – ומשלם בגוף: הצוואר.</a:t>
             </a:r>
             <a:endParaRPr lang="en-US" sz="1050" dirty="0"/>
           </a:p>
@@ -12860,7 +12860,7 @@
                 <a:ea typeface="Arial" pitchFamily="34" charset="-122"/>
                 <a:cs typeface="Arial" pitchFamily="34" charset="-120"/>
               </a:rPr>
-              <a:t>יצירה = הסחת דעת</a:t>
+              <a:t>כתיבה = הסחה או שימור?</a:t>
             </a:r>
             <a:endParaRPr lang="en-US" sz="1250" dirty="0"/>
           </a:p>
@@ -12899,7 +12899,7 @@
                 <a:ea typeface="Arial" pitchFamily="34" charset="-122"/>
                 <a:cs typeface="Arial" pitchFamily="34" charset="-120"/>
               </a:rPr>
-              <a:t>עמדה מטא-פואטית: הכתיבה עצמה כדרך התמודדות עם מציאות קשה (קצמן, 2005; טאוב, 1997).</a:t>
+              <a:t>הזר: לשמר את היופי לנצח. המספר: לכתוב על הצוואר – ההומור והבנאלי כהתמודדות כנה (Schwartz, 2018).</a:t>
             </a:r>
             <a:endParaRPr lang="en-US" sz="1050" dirty="0"/>
           </a:p>

</xml_diff>

<commit_message>
Add list of six peer-reviewed articles with full-text access
Replace the book-heavy core bibliography with six peer-reviewed journal
articles (two Hebrew, four English) that have full-text access, add a
separate Word file describing each article's journal, access link and
contribution, and update the presentation and README accordingly.

Co-Authored-By: Claude Fable 5.1 <noreply@anthropic.com>
Claude-Session: https://claude.ai/code/session_012ZD2wAUBZdU4RRE8wFJx9h
</commit_message>
<xml_diff>
--- a/seminar/מצגת-סמינריון-קרת.pptx
+++ b/seminar/מצגת-סמינריון-קרת.pptx
@@ -5777,8 +5777,8 @@
         </p:nvSpPr>
         <p:spPr>
           <a:xfrm>
-            <a:off x="457200" y="1097280"/>
-            <a:ext cx="8229600" cy="1920240"/>
+            <a:off x="457200" y="1051560"/>
+            <a:ext cx="8229600" cy="1600200"/>
           </a:xfrm>
           <a:prstGeom prst="rect">
             <a:avLst/>
@@ -5797,7 +5797,7 @@
               <a:buNone/>
             </a:pPr>
             <a:r>
-              <a:rPr lang="en-US" sz="1100" dirty="0">
+              <a:rPr lang="en-US" sz="1050" dirty="0">
                 <a:solidFill>
                   <a:srgbClr val="1B2A41"/>
                 </a:solidFill>
@@ -5805,9 +5805,9 @@
                 <a:ea typeface="Arial" pitchFamily="34" charset="-122"/>
                 <a:cs typeface="Arial" pitchFamily="34" charset="-120"/>
               </a:rPr>
-              <a:t>טאוב, ג' (1997). המרד השפוף: על תרבות צעירה בישראל. הקיבוץ המאוחד.</a:t>
-            </a:r>
-            <a:endParaRPr lang="en-US" sz="1100" dirty="0"/>
+              <a:t>כהן, ד' (2015). בשני צירים שונים: תהליך האבל והתקשורת של הורים ואחים שכולים לאחר אבדן ילד בוגר. מפגש לעבודה חינוכית-סוציאלית, כג(41).</a:t>
+            </a:r>
+            <a:endParaRPr lang="en-US" sz="1050" dirty="0"/>
           </a:p>
           <a:p>
             <a:pPr algn="r" indent="0" marL="0">
@@ -5817,7 +5817,7 @@
               <a:buNone/>
             </a:pPr>
             <a:r>
-              <a:rPr lang="en-US" sz="1100" dirty="0">
+              <a:rPr lang="en-US" sz="1050" dirty="0">
                 <a:solidFill>
                   <a:srgbClr val="1B2A41"/>
                 </a:solidFill>
@@ -5825,9 +5825,9 @@
                 <a:ea typeface="Arial" pitchFamily="34" charset="-122"/>
                 <a:cs typeface="Arial" pitchFamily="34" charset="-120"/>
               </a:rPr>
-              <a:t>מנדלסון-מעוז, ע' (1998). סיטואציות קיצוניות, זוועתיות וגרוטסקיות ביצירותיהם של קסטל-בלום וקרת. דפים למחקר בספרות, 11, 269–295.</a:t>
-            </a:r>
-            <a:endParaRPr lang="en-US" sz="1100" dirty="0"/>
+              <a:t>קצמן, ר' (2005). געגועים למיתוס: אישיות, אתיקה ואידאולוגיה במיתופואסיס הפוסטמודרני של אתגר קרת. מכאן, ד, 20–41.</a:t>
+            </a:r>
+            <a:endParaRPr lang="en-US" sz="1050" dirty="0"/>
           </a:p>
           <a:p>
             <a:pPr algn="r" indent="0" marL="0">
@@ -5837,7 +5837,7 @@
               <a:buNone/>
             </a:pPr>
             <a:r>
-              <a:rPr lang="en-US" sz="1100" dirty="0">
+              <a:rPr lang="en-US" sz="1050" dirty="0">
                 <a:solidFill>
                   <a:srgbClr val="1B2A41"/>
                 </a:solidFill>
@@ -5845,9 +5845,9 @@
                 <a:ea typeface="Arial" pitchFamily="34" charset="-122"/>
                 <a:cs typeface="Arial" pitchFamily="34" charset="-120"/>
               </a:rPr>
-              <a:t>קצמן, ר' (2005). געגועים למיתוס: אישיות, אתיקה ואידיאולוגיה במיתופואסיס הפוסטמודרני של אתגר קרת. מכאן, ד, 20–41.</a:t>
-            </a:r>
-            <a:endParaRPr lang="en-US" sz="1100" dirty="0"/>
+              <a:t>קרת, א' (1994). האנשים החלולים. בתוך געגועי לקיסינג'ר. זמורה-ביתן.</a:t>
+            </a:r>
+            <a:endParaRPr lang="en-US" sz="1050" dirty="0"/>
           </a:p>
           <a:p>
             <a:pPr algn="r" indent="0" marL="0">
@@ -5857,7 +5857,7 @@
               <a:buNone/>
             </a:pPr>
             <a:r>
-              <a:rPr lang="en-US" sz="1100" dirty="0">
+              <a:rPr lang="en-US" sz="1050" dirty="0">
                 <a:solidFill>
                   <a:srgbClr val="1B2A41"/>
                 </a:solidFill>
@@ -5865,29 +5865,9 @@
                 <a:ea typeface="Arial" pitchFamily="34" charset="-122"/>
                 <a:cs typeface="Arial" pitchFamily="34" charset="-120"/>
               </a:rPr>
-              <a:t>קרת, א' (1994). האנשים החלולים. בתוך געגועי לקיסינג'ר. זמורה-ביתן.</a:t>
-            </a:r>
-            <a:endParaRPr lang="en-US" sz="1100" dirty="0"/>
-          </a:p>
-          <a:p>
-            <a:pPr algn="r" indent="0" marL="0">
-              <a:spcAft>
-                <a:spcPts val="600"/>
-              </a:spcAft>
-              <a:buNone/>
-            </a:pPr>
-            <a:r>
-              <a:rPr lang="en-US" sz="1100" dirty="0">
-                <a:solidFill>
-                  <a:srgbClr val="1B2A41"/>
-                </a:solidFill>
-                <a:latin typeface="Arial" pitchFamily="34" charset="0"/>
-                <a:ea typeface="Arial" pitchFamily="34" charset="-122"/>
-                <a:cs typeface="Arial" pitchFamily="34" charset="-120"/>
-              </a:rPr>
               <a:t>קרת, א' (2024). מי כמונו יודע. בתוך אוטוקורקט. כנרת, זמורה-ביתן, דביר.</a:t>
             </a:r>
-            <a:endParaRPr lang="en-US" sz="1100" dirty="0"/>
+            <a:endParaRPr lang="en-US" sz="1050" dirty="0"/>
           </a:p>
         </p:txBody>
       </p:sp>
@@ -5899,7 +5879,7 @@
         </p:nvSpPr>
         <p:spPr>
           <a:xfrm>
-            <a:off x="457200" y="3063240"/>
+            <a:off x="457200" y="2697480"/>
             <a:ext cx="8229600" cy="0"/>
           </a:xfrm>
           <a:prstGeom prst="line">
@@ -5922,8 +5902,8 @@
         </p:nvSpPr>
         <p:spPr>
           <a:xfrm>
-            <a:off x="457200" y="3154680"/>
-            <a:ext cx="8229600" cy="1508760"/>
+            <a:off x="457200" y="2788920"/>
+            <a:ext cx="8229600" cy="1874520"/>
           </a:xfrm>
           <a:prstGeom prst="rect">
             <a:avLst/>
@@ -5942,7 +5922,7 @@
               <a:buNone/>
             </a:pPr>
             <a:r>
-              <a:rPr lang="en-US" sz="1100" dirty="0">
+              <a:rPr lang="en-US" sz="1050" dirty="0">
                 <a:solidFill>
                   <a:srgbClr val="1B2A41"/>
                 </a:solidFill>
@@ -5950,9 +5930,9 @@
                 <a:ea typeface="Arial" pitchFamily="34" charset="-122"/>
                 <a:cs typeface="Arial" pitchFamily="34" charset="-120"/>
               </a:rPr>
-              <a:t>Lazarus, R. S., &amp; Folkman, S. (1984). Stress, appraisal, and coping. Springer.</a:t>
-            </a:r>
-            <a:endParaRPr lang="en-US" sz="1100" dirty="0"/>
+              <a:t>Abramovich, D. (2019). Israeli Holocaust memory in a short story by Etgar Keret. Australian Journal of Jewish Studies, 32, 21–33.</a:t>
+            </a:r>
+            <a:endParaRPr lang="en-US" sz="1050" dirty="0"/>
           </a:p>
           <a:p>
             <a:pPr algn="l" indent="0" marL="0">
@@ -5962,7 +5942,7 @@
               <a:buNone/>
             </a:pPr>
             <a:r>
-              <a:rPr lang="en-US" sz="1100" dirty="0">
+              <a:rPr lang="en-US" sz="1050" dirty="0">
                 <a:solidFill>
                   <a:srgbClr val="1B2A41"/>
                 </a:solidFill>
@@ -5970,9 +5950,9 @@
                 <a:ea typeface="Arial" pitchFamily="34" charset="-122"/>
                 <a:cs typeface="Arial" pitchFamily="34" charset="-120"/>
               </a:rPr>
-              <a:t>Omer-Sherman, R. (2020). "To extract from it some sort of beautiful thing": The Holocaust in the families and fiction of Nava Semel and Etgar Keret. Humanities, 9(4), 137. https://doi.org/10.3390/h9040137</a:t>
-            </a:r>
-            <a:endParaRPr lang="en-US" sz="1100" dirty="0"/>
+              <a:t>Mendelson-Maoz, A. (2018). Keret's "living-dead" and the sacrifice of Israeli masculinity. BGU Review: A Journal of Israeli Culture, Winter 2018.</a:t>
+            </a:r>
+            <a:endParaRPr lang="en-US" sz="1050" dirty="0"/>
           </a:p>
           <a:p>
             <a:pPr algn="l" indent="0" marL="0">
@@ -5982,7 +5962,7 @@
               <a:buNone/>
             </a:pPr>
             <a:r>
-              <a:rPr lang="en-US" sz="1100" dirty="0">
+              <a:rPr lang="en-US" sz="1050" dirty="0">
                 <a:solidFill>
                   <a:srgbClr val="1B2A41"/>
                 </a:solidFill>
@@ -5990,9 +5970,29 @@
                 <a:ea typeface="Arial" pitchFamily="34" charset="-122"/>
                 <a:cs typeface="Arial" pitchFamily="34" charset="-120"/>
               </a:rPr>
-              <a:t>Rubin, S. S. (1999). The two-track model of bereavement: Overview, retrospect, and prospect. Death Studies, 23(8), 681–714.</a:t>
-            </a:r>
-            <a:endParaRPr lang="en-US" sz="1100" dirty="0"/>
+              <a:t>Omer-Sherman, R. (2020). "To extract from it some sort of beautiful thing": The Holocaust in the families and fiction of Nava Semel and Etgar Keret. Humanities, 9(4), 137. https://doi.org/10.3390/h9040137</a:t>
+            </a:r>
+            <a:endParaRPr lang="en-US" sz="1050" dirty="0"/>
+          </a:p>
+          <a:p>
+            <a:pPr algn="l" indent="0" marL="0">
+              <a:spcAft>
+                <a:spcPts val="600"/>
+              </a:spcAft>
+              <a:buNone/>
+            </a:pPr>
+            <a:r>
+              <a:rPr lang="en-US" sz="1050" dirty="0">
+                <a:solidFill>
+                  <a:srgbClr val="1B2A41"/>
+                </a:solidFill>
+                <a:latin typeface="Arial" pitchFamily="34" charset="0"/>
+                <a:ea typeface="Arial" pitchFamily="34" charset="-122"/>
+                <a:cs typeface="Arial" pitchFamily="34" charset="-120"/>
+              </a:rPr>
+              <a:t>Schwartz, Y. (2018). Stam: The unbearable lightness of banality, or on the nature of Etgar Keret's humor. BGU Review: A Journal of Israeli Culture, Winter 2018.</a:t>
+            </a:r>
+            <a:endParaRPr lang="en-US" sz="1050" dirty="0"/>
           </a:p>
         </p:txBody>
       </p:sp>

</xml_diff>

<commit_message>
Correct source attributions after reading the five full-text articles
Replace the wrongly attributed Schwartz article (the BGU Review PDF is
"A story or a bullet between the eyes" on repetition, not "Stam"),
rewrite the Katsman claims to his actual reading of "The Hollow People"
(harmony without order, the father's rhetoric of banality, the stolen
voice), fix the Omer-Sherman claim about Keret's vocal rather than silent
home, add page numbers for Cohen and for the story in the 1994 collection,
and update the outline, article list, presentation and README.

Co-Authored-By: Claude Fable 5.1 <noreply@anthropic.com>
Claude-Session: https://claude.ai/code/session_012ZD2wAUBZdU4RRE8wFJx9h
</commit_message>
<xml_diff>
--- a/seminar/מצגת-סמינריון-קרת.pptx
+++ b/seminar/מצגת-סמינריון-קרת.pptx
@@ -4366,7 +4366,7 @@
                 <a:ea typeface="Arial" pitchFamily="34" charset="-122"/>
                 <a:cs typeface="Arial" pitchFamily="34" charset="-120"/>
               </a:rPr>
-              <a:t>לחישת האב ונוסחת האמריקאי משנות את משמעות המציאות, לא את המציאות. הפנטזיה של קרת היא כלי הישרדות (מנדלסון-מעוז; קצמן).</a:t>
+              <a:t>לחישת האב ונוסחת האמריקאי משנות את משמעות המציאות, לא את המציאות. המיתוס של קרת: לחיות את הבעיה בלי לפתור אותה (כצמן, 2005).</a:t>
             </a:r>
             <a:endParaRPr lang="en-US" sz="1150" dirty="0"/>
           </a:p>
@@ -5805,7 +5805,7 @@
                 <a:ea typeface="Arial" pitchFamily="34" charset="-122"/>
                 <a:cs typeface="Arial" pitchFamily="34" charset="-120"/>
               </a:rPr>
-              <a:t>כהן, ד' (2015). בשני צירים שונים: תהליך האבל והתקשורת של הורים ואחים שכולים לאחר אבדן ילד בוגר. מפגש לעבודה חינוכית-סוציאלית, כג(41).</a:t>
+              <a:t>כהן, ד' (2015). בשני צירים שונים: תהליך האבל והתקשורת של הורים ואחים שכולים לאחר אבדן ילד בוגר. מפגש לעבודה חינוכית-סוציאלית, כג(41), 97-130.</a:t>
             </a:r>
             <a:endParaRPr lang="en-US" sz="1050" dirty="0"/>
           </a:p>
@@ -5825,7 +5825,7 @@
                 <a:ea typeface="Arial" pitchFamily="34" charset="-122"/>
                 <a:cs typeface="Arial" pitchFamily="34" charset="-120"/>
               </a:rPr>
-              <a:t>קצמן, ר' (2005). געגועים למיתוס: אישיות, אתיקה ואידאולוגיה במיתופואסיס הפוסטמודרני של אתגר קרת. מכאן, ד, 20–41.</a:t>
+              <a:t>כצמן, ר' (2005). געגועים למיתוס: אישיות, אתיקה ואידיאולוגיה במיתופואסיס הפוסטמודרני של אתגר קרת. מכאן, ד, 20-41.</a:t>
             </a:r>
             <a:endParaRPr lang="en-US" sz="1050" dirty="0"/>
           </a:p>
@@ -5990,7 +5990,7 @@
                 <a:ea typeface="Arial" pitchFamily="34" charset="-122"/>
                 <a:cs typeface="Arial" pitchFamily="34" charset="-120"/>
               </a:rPr>
-              <a:t>Schwartz, Y. (2018). Stam: The unbearable lightness of banality, or on the nature of Etgar Keret's humor. BGU Review: A Journal of Israeli Culture, Winter 2018.</a:t>
+              <a:t>Schwartz, Y. (2018). "A story or a bullet between the eyes": Etgar Keret: Repetitiveness, morality, and postmodernism. BGU Review: A Journal of Israeli Culture, Winter 2018, 1-24.</a:t>
             </a:r>
             <a:endParaRPr lang="en-US" sz="1050" dirty="0"/>
           </a:p>
@@ -8955,7 +8955,7 @@
                 <a:ea typeface="Arial" pitchFamily="34" charset="-122"/>
                 <a:cs typeface="Arial" pitchFamily="34" charset="-120"/>
               </a:rPr>
-              <a:t>סיטואציות קיצוניות שהדמויות מגיבות להן בשגרה (מנדלסון-מעוז, 1998); בניית עולם פרטי עם חוקים משלו (קצמן, 2005); נסיגה מן הציבורי אל האינטימי (טאוב, 1997).</a:t>
+              <a:t>מיתוס כ"הרמוניה ללא סדר": לחיות בעיה בלי לפתור אותה (כצמן, 2005); חזרה מכנית ומוטציה נרטיבית (Schwartz, 2018); הגבריות החלשה של האבות (Mendelson-Maoz, 2018).</a:t>
             </a:r>
             <a:endParaRPr lang="en-US" sz="1150" dirty="0"/>
           </a:p>
@@ -10589,7 +10589,7 @@
                 <a:ea typeface="Arial" pitchFamily="34" charset="-122"/>
                 <a:cs typeface="Arial" pitchFamily="34" charset="-120"/>
               </a:rPr>
-              <a:t>האב מרוקן את האיום מגוף וממשמעות. הגרוטסקה כהגנה (מנדלסון-מעוז, 1998).</a:t>
+              <a:t>"רטוריקת הסתמיות של אבא": מרגיעה את הגוף, אבל דווקא הקול החוזר מפחיד (כצמן, 2005).</a:t>
             </a:r>
             <a:endParaRPr lang="en-US" sz="1050" dirty="0"/>
           </a:p>
@@ -10927,7 +10927,7 @@
                 <a:ea typeface="Arial" pitchFamily="34" charset="-122"/>
                 <a:cs typeface="Arial" pitchFamily="34" charset="-120"/>
               </a:rPr>
-              <a:t>שתיקה על הקבר, "סתם" – מי שחי בין קולות חלולים נעשה חלול (Rubin, 1999; Schwartz, 2018).</a:t>
+              <a:t>שתיקה על הקבר, "סתם" – הקול הגנוב: מי שחוזר על קולות חלולים נעשה חלול (כצמן, 2005; Rubin, 1999).</a:t>
             </a:r>
             <a:endParaRPr lang="en-US" sz="1050" dirty="0"/>
           </a:p>
@@ -12899,7 +12899,7 @@
                 <a:ea typeface="Arial" pitchFamily="34" charset="-122"/>
                 <a:cs typeface="Arial" pitchFamily="34" charset="-120"/>
               </a:rPr>
-              <a:t>הזר: לשמר את היופי לנצח. המספר: לכתוב על הצוואר – ההומור והבנאלי כהתמודדות כנה (Schwartz, 2018).</a:t>
+              <a:t>הזר: לשמר את היופי לנצח. המספר: לכתוב על הצוואר – המוטציה הקטנה שעוצרת את לולאת החזרות (Schwartz, 2018).</a:t>
             </a:r>
             <a:endParaRPr lang="en-US" sz="1050" dirty="0"/>
           </a:p>

</xml_diff>

<commit_message>
Add the college logo to the cover pages and the title slide
Co-Authored-By: Claude Fable 5.1 <noreply@anthropic.com>
Claude-Session: https://claude.ai/code/session_012ZD2wAUBZdU4RRE8wFJx9h
</commit_message>
<xml_diff>
--- a/seminar/מצגת-סמינריון-קרת.pptx
+++ b/seminar/מצגת-סמינריון-קרת.pptx
@@ -2034,14 +2034,65 @@
       </p:grpSpPr>
       <p:sp>
         <p:nvSpPr>
-          <p:cNvPr id="2" name="Text 0"/>
+          <p:cNvPr id="2" name="Shape 0"/>
+          <p:cNvSpPr/>
+          <p:nvPr/>
+        </p:nvSpPr>
+        <p:spPr>
+          <a:xfrm>
+            <a:off x="6629400" y="274320"/>
+            <a:ext cx="2057400" cy="1280160"/>
+          </a:xfrm>
+          <a:prstGeom prst="roundRect">
+            <a:avLst>
+              <a:gd name="adj" fmla="val 7143"/>
+            </a:avLst>
+          </a:prstGeom>
+          <a:solidFill>
+            <a:srgbClr val="FFFFFF"/>
+          </a:solidFill>
+          <a:ln w="12700">
+            <a:solidFill>
+              <a:srgbClr val="FFFFFF"/>
+            </a:solidFill>
+            <a:prstDash val="solid"/>
+          </a:ln>
+        </p:spPr>
+      </p:sp>
+      <p:pic>
+        <p:nvPicPr>
+          <p:cNvPr id="3" name="Image 0" descr="/home/user/clickwriting-landing/seminar/logo-college.png">    </p:cNvPr>
+          <p:cNvPicPr>
+            <a:picLocks noChangeAspect="1"/>
+          </p:cNvPicPr>
+          <p:nvPr/>
+        </p:nvPicPr>
+        <p:blipFill>
+          <a:blip r:embed="rId1"/>
+          <a:stretch>
+            <a:fillRect/>
+          </a:stretch>
+        </p:blipFill>
+        <p:spPr>
+          <a:xfrm>
+            <a:off x="6766560" y="347472"/>
+            <a:ext cx="1783080" cy="1115568"/>
+          </a:xfrm>
+          <a:prstGeom prst="rect">
+            <a:avLst/>
+          </a:prstGeom>
+        </p:spPr>
+      </p:pic>
+      <p:sp>
+        <p:nvSpPr>
+          <p:cNvPr id="4" name="Text 1"/>
           <p:cNvSpPr txBox="1"/>
           <p:nvPr/>
         </p:nvSpPr>
         <p:spPr>
           <a:xfrm>
             <a:off x="548640" y="365760"/>
-            <a:ext cx="8046720" cy="365760"/>
+            <a:ext cx="5852160" cy="365760"/>
           </a:xfrm>
           <a:prstGeom prst="rect">
             <a:avLst/>
@@ -2073,14 +2124,14 @@
       </p:sp>
       <p:sp>
         <p:nvSpPr>
-          <p:cNvPr id="3" name="Text 1"/>
+          <p:cNvPr id="5" name="Text 2"/>
           <p:cNvSpPr txBox="1"/>
           <p:nvPr/>
         </p:nvSpPr>
         <p:spPr>
           <a:xfrm>
             <a:off x="548640" y="731520"/>
-            <a:ext cx="8046720" cy="365760"/>
+            <a:ext cx="5852160" cy="365760"/>
           </a:xfrm>
           <a:prstGeom prst="rect">
             <a:avLst/>
@@ -2112,7 +2163,7 @@
       </p:sp>
       <p:sp>
         <p:nvSpPr>
-          <p:cNvPr id="4" name="Text 2"/>
+          <p:cNvPr id="6" name="Text 3"/>
           <p:cNvSpPr txBox="1"/>
           <p:nvPr/>
         </p:nvSpPr>
@@ -2151,7 +2202,7 @@
       </p:sp>
       <p:sp>
         <p:nvSpPr>
-          <p:cNvPr id="5" name="Text 3"/>
+          <p:cNvPr id="7" name="Text 4"/>
           <p:cNvSpPr txBox="1"/>
           <p:nvPr/>
         </p:nvSpPr>
@@ -2190,7 +2241,7 @@
       </p:sp>
       <p:sp>
         <p:nvSpPr>
-          <p:cNvPr id="6" name="Text 4"/>
+          <p:cNvPr id="8" name="Text 5"/>
           <p:cNvSpPr txBox="1"/>
           <p:nvPr/>
         </p:nvSpPr>
@@ -2229,7 +2280,7 @@
       </p:sp>
       <p:sp>
         <p:nvSpPr>
-          <p:cNvPr id="7" name="Shape 5"/>
+          <p:cNvPr id="9" name="Shape 6"/>
           <p:cNvSpPr/>
           <p:nvPr/>
         </p:nvSpPr>
@@ -2256,7 +2307,7 @@
       </p:sp>
       <p:sp>
         <p:nvSpPr>
-          <p:cNvPr id="8" name="Text 6"/>
+          <p:cNvPr id="10" name="Text 7"/>
           <p:cNvSpPr txBox="1"/>
           <p:nvPr/>
         </p:nvSpPr>

</xml_diff>